<commit_message>
evaluation: add auditable public benchmark protocol
</commit_message>
<xml_diff>
--- a/deliverables/DevOrbit_初赛方案.pptx
+++ b/deliverables/DevOrbit_初赛方案.pptx
@@ -79,7 +79,7 @@
         <p:txBody>
           <a:bodyPr/>
           <a:p>
-            <a:fld id="{EC61F676-BA6A-4E64-A421-4E6D929DBBCD}" type="slidenum">
+            <a:fld id="{0D0A30FA-C1A1-4A60-A029-F22DECE92122}" type="slidenum">
               <a:t>&lt;#&gt;</a:t>
             </a:fld>
           </a:p>
@@ -267,7 +267,7 @@
         <p:txBody>
           <a:bodyPr/>
           <a:p>
-            <a:fld id="{C8775858-5AB9-4DCF-802F-DA93E5851D78}" type="slidenum">
+            <a:fld id="{0ADE748E-06C5-40EF-9FD1-0F17995E65C6}" type="slidenum">
               <a:t>&lt;#&gt;</a:t>
             </a:fld>
           </a:p>
@@ -523,7 +523,7 @@
         <p:txBody>
           <a:bodyPr/>
           <a:p>
-            <a:fld id="{7B3BBF42-80E4-4025-99EF-EC8FD619D034}" type="slidenum">
+            <a:fld id="{1506F728-1EE8-41B0-A4EE-ED773D317938}" type="slidenum">
               <a:t>&lt;#&gt;</a:t>
             </a:fld>
           </a:p>
@@ -847,7 +847,7 @@
         <p:txBody>
           <a:bodyPr/>
           <a:p>
-            <a:fld id="{F3C4E724-E6BB-4C37-B195-DE2653A021DC}" type="slidenum">
+            <a:fld id="{1B5CAFEC-30A9-43BD-8F26-3A180B1F2024}" type="slidenum">
               <a:t>&lt;#&gt;</a:t>
             </a:fld>
           </a:p>
@@ -1004,7 +1004,7 @@
         <p:txBody>
           <a:bodyPr/>
           <a:p>
-            <a:fld id="{AD07E860-C55E-44B0-83B7-7FF07A815607}" type="slidenum">
+            <a:fld id="{99126289-4CBE-4EC7-BE54-E37C42F53221}" type="slidenum">
               <a:t>&lt;#&gt;</a:t>
             </a:fld>
           </a:p>
@@ -1158,7 +1158,7 @@
         <p:txBody>
           <a:bodyPr/>
           <a:p>
-            <a:fld id="{C30708B1-BAC5-4665-AECC-9E1AA3E0E010}" type="slidenum">
+            <a:fld id="{5BC41C88-9B3D-4AC0-AB04-20167CD4472E}" type="slidenum">
               <a:t>&lt;#&gt;</a:t>
             </a:fld>
           </a:p>
@@ -1346,7 +1346,7 @@
         <p:txBody>
           <a:bodyPr/>
           <a:p>
-            <a:fld id="{EF9DA2D7-76B6-43CD-BD9A-584CD9A5123B}" type="slidenum">
+            <a:fld id="{F116375D-7BB4-4F9B-868E-C047DF46DCDA}" type="slidenum">
               <a:t>&lt;#&gt;</a:t>
             </a:fld>
           </a:p>
@@ -1466,7 +1466,7 @@
         <p:txBody>
           <a:bodyPr/>
           <a:p>
-            <a:fld id="{B8AA1EF8-B3D2-45F8-BD44-52A5A6DCCAB5}" type="slidenum">
+            <a:fld id="{BC1C7D7C-9CDB-49E8-9ACB-5ECA3AD6009F}" type="slidenum">
               <a:t>&lt;#&gt;</a:t>
             </a:fld>
           </a:p>
@@ -1586,7 +1586,7 @@
         <p:txBody>
           <a:bodyPr/>
           <a:p>
-            <a:fld id="{A3F9584D-D24F-4963-A9F9-5011343F645C}" type="slidenum">
+            <a:fld id="{AAA11D29-5576-4490-9278-D2A155FE966E}" type="slidenum">
               <a:t>&lt;#&gt;</a:t>
             </a:fld>
           </a:p>
@@ -1808,7 +1808,7 @@
         <p:txBody>
           <a:bodyPr/>
           <a:p>
-            <a:fld id="{2D7818F1-39DE-4673-9C8D-8DB0F1B524D8}" type="slidenum">
+            <a:fld id="{8A5BEDCF-5881-44E0-A153-3106762AE3A7}" type="slidenum">
               <a:t>&lt;#&gt;</a:t>
             </a:fld>
           </a:p>
@@ -2030,7 +2030,7 @@
         <p:txBody>
           <a:bodyPr/>
           <a:p>
-            <a:fld id="{8C4563E7-E69A-41AC-9350-C82D4200D2B9}" type="slidenum">
+            <a:fld id="{F65A88BE-1C04-4C63-84C8-41459AFFEC2E}" type="slidenum">
               <a:t>&lt;#&gt;</a:t>
             </a:fld>
           </a:p>
@@ -2252,7 +2252,7 @@
         <p:txBody>
           <a:bodyPr/>
           <a:p>
-            <a:fld id="{DF0A611C-2DF9-424D-B26C-13B23720B888}" type="slidenum">
+            <a:fld id="{BFAE9786-A490-4DB6-9D2B-18E6750FA0CD}" type="slidenum">
               <a:t>&lt;#&gt;</a:t>
             </a:fld>
           </a:p>
@@ -2664,7 +2664,7 @@
             <a:pPr algn="r">
               <a:buNone/>
             </a:pPr>
-            <a:fld id="{55D4F501-B8EE-471B-8244-3DDE0CE7AC06}" type="slidenum">
+            <a:fld id="{FAC8F1D0-1EEB-4C09-90A5-2F2098690632}" type="slidenum">
               <a:rPr b="0" lang="en-US" sz="1400" spc="-1" strike="noStrike">
                 <a:latin typeface="Times New Roman"/>
               </a:rPr>
@@ -3117,7 +3117,7 @@
                 </a:solidFill>
                 <a:latin typeface="Noto Sans CJK SC"/>
               </a:rPr>
-              <a:t>· V0.4</a:t>
+              <a:t>· V0.5.1</a:t>
             </a:r>
             <a:endParaRPr b="1" lang="en-US" sz="1300" spc="-1" strike="noStrike">
               <a:solidFill>
@@ -4640,7 +4640,7 @@
                 </a:solidFill>
                 <a:latin typeface="Noto Sans CJK SC"/>
               </a:rPr>
-              <a:t>V0.4 → </a:t>
+              <a:t>V0.5.1 → </a:t>
             </a:r>
             <a:r>
               <a:rPr b="0" lang="zh-CN" sz="1800" spc="-1" strike="noStrike">

</xml_diff>

<commit_message>
feat: add native software delivery platform connectors
</commit_message>
<xml_diff>
--- a/deliverables/DevOrbit_初赛方案.pptx
+++ b/deliverables/DevOrbit_初赛方案.pptx
@@ -79,7 +79,7 @@
         <p:txBody>
           <a:bodyPr/>
           <a:p>
-            <a:fld id="{0D0A30FA-C1A1-4A60-A029-F22DECE92122}" type="slidenum">
+            <a:fld id="{A5CD995C-AF71-4D1F-8FFC-8856C3D4B336}" type="slidenum">
               <a:t>&lt;#&gt;</a:t>
             </a:fld>
           </a:p>
@@ -267,7 +267,7 @@
         <p:txBody>
           <a:bodyPr/>
           <a:p>
-            <a:fld id="{0ADE748E-06C5-40EF-9FD1-0F17995E65C6}" type="slidenum">
+            <a:fld id="{C4CDB6CE-D05B-4FD2-B265-F45F376C980F}" type="slidenum">
               <a:t>&lt;#&gt;</a:t>
             </a:fld>
           </a:p>
@@ -523,7 +523,7 @@
         <p:txBody>
           <a:bodyPr/>
           <a:p>
-            <a:fld id="{1506F728-1EE8-41B0-A4EE-ED773D317938}" type="slidenum">
+            <a:fld id="{1E3B9368-A05B-4E4C-AE37-E2DB3A6EE76C}" type="slidenum">
               <a:t>&lt;#&gt;</a:t>
             </a:fld>
           </a:p>
@@ -847,7 +847,7 @@
         <p:txBody>
           <a:bodyPr/>
           <a:p>
-            <a:fld id="{1B5CAFEC-30A9-43BD-8F26-3A180B1F2024}" type="slidenum">
+            <a:fld id="{9E0ADD66-2E0D-4711-AF07-DD2BD232DEB3}" type="slidenum">
               <a:t>&lt;#&gt;</a:t>
             </a:fld>
           </a:p>
@@ -1004,7 +1004,7 @@
         <p:txBody>
           <a:bodyPr/>
           <a:p>
-            <a:fld id="{99126289-4CBE-4EC7-BE54-E37C42F53221}" type="slidenum">
+            <a:fld id="{74C6EB12-8C1E-487E-817F-05CA58EF493E}" type="slidenum">
               <a:t>&lt;#&gt;</a:t>
             </a:fld>
           </a:p>
@@ -1158,7 +1158,7 @@
         <p:txBody>
           <a:bodyPr/>
           <a:p>
-            <a:fld id="{5BC41C88-9B3D-4AC0-AB04-20167CD4472E}" type="slidenum">
+            <a:fld id="{9AE9C975-F4EB-4199-9302-8A1F62A63240}" type="slidenum">
               <a:t>&lt;#&gt;</a:t>
             </a:fld>
           </a:p>
@@ -1346,7 +1346,7 @@
         <p:txBody>
           <a:bodyPr/>
           <a:p>
-            <a:fld id="{F116375D-7BB4-4F9B-868E-C047DF46DCDA}" type="slidenum">
+            <a:fld id="{17B70F4A-3331-40BA-B0D6-D0C9A0CC24FC}" type="slidenum">
               <a:t>&lt;#&gt;</a:t>
             </a:fld>
           </a:p>
@@ -1466,7 +1466,7 @@
         <p:txBody>
           <a:bodyPr/>
           <a:p>
-            <a:fld id="{BC1C7D7C-9CDB-49E8-9ACB-5ECA3AD6009F}" type="slidenum">
+            <a:fld id="{96E70AF4-A9C4-4BF7-9F44-E6FABAE9E792}" type="slidenum">
               <a:t>&lt;#&gt;</a:t>
             </a:fld>
           </a:p>
@@ -1586,7 +1586,7 @@
         <p:txBody>
           <a:bodyPr/>
           <a:p>
-            <a:fld id="{AAA11D29-5576-4490-9278-D2A155FE966E}" type="slidenum">
+            <a:fld id="{2CCA6500-E8EE-4FC4-95A7-5D4BCB7558F0}" type="slidenum">
               <a:t>&lt;#&gt;</a:t>
             </a:fld>
           </a:p>
@@ -1808,7 +1808,7 @@
         <p:txBody>
           <a:bodyPr/>
           <a:p>
-            <a:fld id="{8A5BEDCF-5881-44E0-A153-3106762AE3A7}" type="slidenum">
+            <a:fld id="{F2022E98-2D38-4D7C-A26E-CBA1AD05DBAC}" type="slidenum">
               <a:t>&lt;#&gt;</a:t>
             </a:fld>
           </a:p>
@@ -2030,7 +2030,7 @@
         <p:txBody>
           <a:bodyPr/>
           <a:p>
-            <a:fld id="{F65A88BE-1C04-4C63-84C8-41459AFFEC2E}" type="slidenum">
+            <a:fld id="{466AB753-0018-45F6-89FD-88456C161E3E}" type="slidenum">
               <a:t>&lt;#&gt;</a:t>
             </a:fld>
           </a:p>
@@ -2252,7 +2252,7 @@
         <p:txBody>
           <a:bodyPr/>
           <a:p>
-            <a:fld id="{BFAE9786-A490-4DB6-9D2B-18E6750FA0CD}" type="slidenum">
+            <a:fld id="{5D486792-CC87-47F4-AF59-AA78E6F38F49}" type="slidenum">
               <a:t>&lt;#&gt;</a:t>
             </a:fld>
           </a:p>
@@ -2664,7 +2664,7 @@
             <a:pPr algn="r">
               <a:buNone/>
             </a:pPr>
-            <a:fld id="{FAC8F1D0-1EEB-4C09-90A5-2F2098690632}" type="slidenum">
+            <a:fld id="{71A11149-761D-42A7-9FF2-A97800F00501}" type="slidenum">
               <a:rPr b="0" lang="en-US" sz="1400" spc="-1" strike="noStrike">
                 <a:latin typeface="Times New Roman"/>
               </a:rPr>
@@ -3117,7 +3117,7 @@
                 </a:solidFill>
                 <a:latin typeface="Noto Sans CJK SC"/>
               </a:rPr>
-              <a:t>· V0.5.1</a:t>
+              <a:t>· V0.6.0</a:t>
             </a:r>
             <a:endParaRPr b="1" lang="en-US" sz="1300" spc="-1" strike="noStrike">
               <a:solidFill>
@@ -4033,7 +4033,7 @@
                 </a:solidFill>
                 <a:latin typeface="Noto Sans CJK SC"/>
               </a:rPr>
-              <a:t>verify-all / AgentTeams contract / POST /mcp</a:t>
+              <a:t>verify-production / native-platform-smoke / POST /mcp</a:t>
             </a:r>
             <a:endParaRPr b="0" lang="en-US" sz="1800" spc="-1" strike="noStrike">
               <a:solidFill>
@@ -4117,15 +4117,15 @@
           </a:bodyPr>
           <a:p>
             <a:r>
-              <a:rPr b="1" lang="en-US" sz="1900" spc="-1" strike="noStrike">
-                <a:solidFill>
-                  <a:srgbClr val="12231d"/>
-                </a:solidFill>
-                <a:latin typeface="Noto Sans CJK SC"/>
-              </a:rPr>
-              <a:t>7 Worker · OTLP Agent/Tool Span</a:t>
-            </a:r>
-            <a:endParaRPr b="1" lang="en-US" sz="1900" spc="-1" strike="noStrike">
+              <a:rPr b="1" lang="en-US" sz="1500" spc="-1" strike="noStrike">
+                <a:solidFill>
+                  <a:srgbClr val="12231d"/>
+                </a:solidFill>
+                <a:latin typeface="Noto Sans CJK SC"/>
+              </a:rPr>
+              <a:t>29/29 Unit · 7/7 Golden · 6/6 Security</a:t>
+            </a:r>
+            <a:endParaRPr b="1" lang="en-US" sz="1500" spc="-1" strike="noStrike">
               <a:solidFill>
                 <a:srgbClr val="12231d"/>
               </a:solidFill>
@@ -4134,33 +4134,15 @@
           </a:p>
           <a:p>
             <a:r>
-              <a:rPr b="1" lang="en-US" sz="1900" spc="-1" strike="noStrike">
-                <a:solidFill>
-                  <a:srgbClr val="12231d"/>
-                </a:solidFill>
-                <a:latin typeface="Noto Sans CJK SC"/>
-              </a:rPr>
-              <a:t>10 MCP Tools · </a:t>
-            </a:r>
-            <a:r>
-              <a:rPr b="1" lang="zh-CN" sz="1900" spc="-1" strike="noStrike">
-                <a:solidFill>
-                  <a:srgbClr val="12231d"/>
-                </a:solidFill>
-                <a:latin typeface="Noto Sans CJK SC"/>
-              </a:rPr>
-              <a:t>运行时 </a:t>
-            </a:r>
-            <a:r>
-              <a:rPr b="1" lang="en-US" sz="1900" spc="-1" strike="noStrike">
-                <a:solidFill>
-                  <a:srgbClr val="12231d"/>
-                </a:solidFill>
-                <a:latin typeface="Noto Sans CJK SC"/>
-              </a:rPr>
-              <a:t>Schema</a:t>
-            </a:r>
-            <a:endParaRPr b="1" lang="en-US" sz="1900" spc="-1" strike="noStrike">
+              <a:rPr b="1" lang="en-US" sz="1500" spc="-1" strike="noStrike">
+                <a:solidFill>
+                  <a:srgbClr val="12231d"/>
+                </a:solidFill>
+                <a:latin typeface="Noto Sans CJK SC"/>
+              </a:rPr>
+              <a:t>AgentTeams 140/140 · Adapter 66/66</a:t>
+            </a:r>
+            <a:endParaRPr b="1" lang="en-US" sz="1500" spc="-1" strike="noStrike">
               <a:solidFill>
                 <a:srgbClr val="12231d"/>
               </a:solidFill>
@@ -4169,15 +4151,24 @@
           </a:p>
           <a:p>
             <a:r>
-              <a:rPr b="1" lang="en-US" sz="1900" spc="-1" strike="noStrike">
-                <a:solidFill>
-                  <a:srgbClr val="12231d"/>
-                </a:solidFill>
-                <a:latin typeface="Noto Sans CJK SC"/>
-              </a:rPr>
-              <a:t>7/7 Golden Cases · 6/6 Security</a:t>
-            </a:r>
-            <a:endParaRPr b="1" lang="en-US" sz="1900" spc="-1" strike="noStrike">
+              <a:rPr b="1" lang="zh-CN" sz="1500" spc="-1" strike="noStrike">
+                <a:solidFill>
+                  <a:srgbClr val="12231d"/>
+                </a:solidFill>
+                <a:latin typeface="Noto Sans CJK SC"/>
+              </a:rPr>
+              <a:t>原生连接器 </a:t>
+            </a:r>
+            <a:r>
+              <a:rPr b="1" lang="en-US" sz="1500" spc="-1" strike="noStrike">
+                <a:solidFill>
+                  <a:srgbClr val="12231d"/>
+                </a:solidFill>
+                <a:latin typeface="Noto Sans CJK SC"/>
+              </a:rPr>
+              <a:t>8/8 · Native Runner 6/6</a:t>
+            </a:r>
+            <a:endParaRPr b="1" lang="en-US" sz="1500" spc="-1" strike="noStrike">
               <a:solidFill>
                 <a:srgbClr val="12231d"/>
               </a:solidFill>
@@ -4186,16 +4177,25 @@
           </a:p>
           <a:p>
             <a:r>
-              <a:rPr b="1" lang="en-US" sz="1900" spc="-1" strike="noStrike">
-                <a:solidFill>
-                  <a:srgbClr val="12231d"/>
-                </a:solidFill>
-                <a:latin typeface="Noto Sans CJK SC"/>
-              </a:rPr>
-              <a:t>7 </a:t>
-            </a:r>
-            <a:r>
-              <a:rPr b="1" lang="zh-CN" sz="1900" spc="-1" strike="noStrike">
+              <a:rPr b="1" lang="zh-CN" sz="1500" spc="-1" strike="noStrike">
+                <a:solidFill>
+                  <a:srgbClr val="12231d"/>
+                </a:solidFill>
+                <a:latin typeface="Noto Sans CJK SC"/>
+              </a:rPr>
+              <a:t>普通容器 </a:t>
+            </a:r>
+            <a:r>
+              <a:rPr b="1" lang="en-US" sz="1500" spc="-1" strike="noStrike">
+                <a:solidFill>
+                  <a:srgbClr val="12231d"/>
+                </a:solidFill>
+                <a:latin typeface="Noto Sans CJK SC"/>
+              </a:rPr>
+              <a:t>14/14 · 7 </a:t>
+            </a:r>
+            <a:r>
+              <a:rPr b="1" lang="zh-CN" sz="1500" spc="-1" strike="noStrike">
                 <a:solidFill>
                   <a:srgbClr val="12231d"/>
                 </a:solidFill>
@@ -4204,7 +4204,7 @@
               <a:t>组对照</a:t>
             </a:r>
             <a:r>
-              <a:rPr b="1" lang="en-US" sz="1900" spc="-1" strike="noStrike">
+              <a:rPr b="1" lang="en-US" sz="1500" spc="-1" strike="noStrike">
                 <a:solidFill>
                   <a:srgbClr val="12231d"/>
                 </a:solidFill>
@@ -4213,7 +4213,7 @@
               <a:t>/</a:t>
             </a:r>
             <a:r>
-              <a:rPr b="1" lang="zh-CN" sz="1900" spc="-1" strike="noStrike">
+              <a:rPr b="1" lang="zh-CN" sz="1500" spc="-1" strike="noStrike">
                 <a:solidFill>
                   <a:srgbClr val="12231d"/>
                 </a:solidFill>
@@ -4221,7 +4221,7 @@
               </a:rPr>
               <a:t>消融</a:t>
             </a:r>
-            <a:endParaRPr b="1" lang="en-US" sz="1900" spc="-1" strike="noStrike">
+            <a:endParaRPr b="1" lang="en-US" sz="1500" spc="-1" strike="noStrike">
               <a:solidFill>
                 <a:srgbClr val="12231d"/>
               </a:solidFill>
@@ -4255,24 +4255,77 @@
           </a:bodyPr>
           <a:p>
             <a:r>
-              <a:rPr b="1" lang="en-US" sz="1700" spc="-1" strike="noStrike">
+              <a:rPr b="1" lang="en-US" sz="1400" spc="-1" strike="noStrike">
                 <a:solidFill>
                   <a:srgbClr val="0e7053"/>
                 </a:solidFill>
                 <a:latin typeface="Noto Sans CJK SC"/>
               </a:rPr>
-              <a:t>AgentTeams v1.2.2 · 140/140 </a:t>
-            </a:r>
-            <a:r>
-              <a:rPr b="1" lang="zh-CN" sz="1700" spc="-1" strike="noStrike">
+              <a:t>Argo JSON Patch + observedGeneration</a:t>
+            </a:r>
+            <a:endParaRPr b="1" lang="en-US" sz="1400" spc="-1" strike="noStrike">
+              <a:solidFill>
+                <a:srgbClr val="0e7053"/>
+              </a:solidFill>
+              <a:latin typeface="Noto Sans CJK SC"/>
+            </a:endParaRPr>
+          </a:p>
+          <a:p>
+            <a:r>
+              <a:rPr b="1" lang="en-US" sz="1400" spc="-1" strike="noStrike">
                 <a:solidFill>
                   <a:srgbClr val="0e7053"/>
                 </a:solidFill>
                 <a:latin typeface="Noto Sans CJK SC"/>
               </a:rPr>
-              <a:t>契约检查</a:t>
-            </a:r>
-            <a:endParaRPr b="1" lang="en-US" sz="1700" spc="-1" strike="noStrike">
+              <a:t>FD </a:t>
+            </a:r>
+            <a:r>
+              <a:rPr b="1" lang="zh-CN" sz="1400" spc="-1" strike="noStrike">
+                <a:solidFill>
+                  <a:srgbClr val="0e7053"/>
+                </a:solidFill>
+                <a:latin typeface="Noto Sans CJK SC"/>
+              </a:rPr>
+              <a:t>锚定防逃逸 </a:t>
+            </a:r>
+            <a:r>
+              <a:rPr b="1" lang="en-US" sz="1400" spc="-1" strike="noStrike">
+                <a:solidFill>
+                  <a:srgbClr val="0e7053"/>
+                </a:solidFill>
+                <a:latin typeface="Noto Sans CJK SC"/>
+              </a:rPr>
+              <a:t>· </a:t>
+            </a:r>
+            <a:r>
+              <a:rPr b="1" lang="zh-CN" sz="1400" spc="-1" strike="noStrike">
+                <a:solidFill>
+                  <a:srgbClr val="0e7053"/>
+                </a:solidFill>
+                <a:latin typeface="Noto Sans CJK SC"/>
+              </a:rPr>
+              <a:t>持久幂等 </a:t>
+            </a:r>
+            <a:r>
+              <a:rPr b="1" lang="en-US" sz="1400" spc="-1" strike="noStrike">
+                <a:solidFill>
+                  <a:srgbClr val="0e7053"/>
+                </a:solidFill>
+                <a:latin typeface="Noto Sans CJK SC"/>
+              </a:rPr>
+              <a:t>/ in_doubt </a:t>
+            </a:r>
+            <a:r>
+              <a:rPr b="1" lang="zh-CN" sz="1400" spc="-1" strike="noStrike">
+                <a:solidFill>
+                  <a:srgbClr val="0e7053"/>
+                </a:solidFill>
+                <a:latin typeface="Noto Sans CJK SC"/>
+              </a:rPr>
+              <a:t>对账</a:t>
+            </a:r>
+            <a:endParaRPr b="1" lang="en-US" sz="1400" spc="-1" strike="noStrike">
               <a:solidFill>
                 <a:srgbClr val="0e7053"/>
               </a:solidFill>
@@ -4281,77 +4334,86 @@
           </a:p>
           <a:p>
             <a:r>
-              <a:rPr b="1" lang="zh-CN" sz="1700" spc="-1" strike="noStrike">
+              <a:rPr b="1" lang="en-US" sz="1400" spc="-1" strike="noStrike">
                 <a:solidFill>
                   <a:srgbClr val="0e7053"/>
                 </a:solidFill>
                 <a:latin typeface="Noto Sans CJK SC"/>
               </a:rPr>
-              <a:t>完整策略 </a:t>
-            </a:r>
-            <a:r>
-              <a:rPr b="1" lang="en-US" sz="1700" spc="-1" strike="noStrike">
+              <a:t>SWE-bench pilot</a:t>
+            </a:r>
+            <a:r>
+              <a:rPr b="1" lang="zh-CN" sz="1400" spc="-1" strike="noStrike">
                 <a:solidFill>
                   <a:srgbClr val="0e7053"/>
                 </a:solidFill>
                 <a:latin typeface="Noto Sans CJK SC"/>
               </a:rPr>
-              <a:t>100% </a:t>
-            </a:r>
-            <a:r>
-              <a:rPr b="1" lang="zh-CN" sz="1700" spc="-1" strike="noStrike">
+              <a:t>：失败复现；</a:t>
+            </a:r>
+            <a:r>
+              <a:rPr b="1" lang="en-US" sz="1400" spc="-1" strike="noStrike">
                 <a:solidFill>
                   <a:srgbClr val="0e7053"/>
                 </a:solidFill>
                 <a:latin typeface="Noto Sans CJK SC"/>
               </a:rPr>
-              <a:t>决策</a:t>
-            </a:r>
-            <a:r>
-              <a:rPr b="1" lang="en-US" sz="1700" spc="-1" strike="noStrike">
+              <a:t>gold 1/1 + 43/43</a:t>
+            </a:r>
+            <a:endParaRPr b="1" lang="en-US" sz="1400" spc="-1" strike="noStrike">
+              <a:solidFill>
+                <a:srgbClr val="0e7053"/>
+              </a:solidFill>
+              <a:latin typeface="Noto Sans CJK SC"/>
+            </a:endParaRPr>
+          </a:p>
+          <a:p>
+            <a:r>
+              <a:rPr b="1" lang="zh-CN" sz="1400" spc="-1" strike="noStrike">
                 <a:solidFill>
                   <a:srgbClr val="0e7053"/>
                 </a:solidFill>
                 <a:latin typeface="Noto Sans CJK SC"/>
               </a:rPr>
+              <a:t>正式分数 </a:t>
+            </a:r>
+            <a:r>
+              <a:rPr b="1" lang="en-US" sz="1400" spc="-1" strike="noStrike">
+                <a:solidFill>
+                  <a:srgbClr val="0e7053"/>
+                </a:solidFill>
+                <a:latin typeface="Noto Sans CJK SC"/>
+              </a:rPr>
+              <a:t>0 · </a:t>
+            </a:r>
+            <a:r>
+              <a:rPr b="1" lang="zh-CN" sz="1400" spc="-1" strike="noStrike">
+                <a:solidFill>
+                  <a:srgbClr val="0e7053"/>
+                </a:solidFill>
+                <a:latin typeface="Noto Sans CJK SC"/>
+              </a:rPr>
+              <a:t>厂商账号</a:t>
+            </a:r>
+            <a:r>
+              <a:rPr b="1" lang="en-US" sz="1400" spc="-1" strike="noStrike">
+                <a:solidFill>
+                  <a:srgbClr val="0e7053"/>
+                </a:solidFill>
+                <a:latin typeface="Noto Sans CJK SC"/>
+              </a:rPr>
               <a:t>/</a:t>
             </a:r>
             <a:r>
-              <a:rPr b="1" lang="zh-CN" sz="1700" spc="-1" strike="noStrike">
+              <a:rPr b="1" lang="zh-CN" sz="1400" spc="-1" strike="noStrike">
                 <a:solidFill>
                   <a:srgbClr val="0e7053"/>
                 </a:solidFill>
                 <a:latin typeface="Noto Sans CJK SC"/>
               </a:rPr>
-              <a:t>安全；朴素基线 </a:t>
-            </a:r>
-            <a:r>
-              <a:rPr b="1" lang="en-US" sz="1700" spc="-1" strike="noStrike">
-                <a:solidFill>
-                  <a:srgbClr val="0e7053"/>
-                </a:solidFill>
-                <a:latin typeface="Noto Sans CJK SC"/>
-              </a:rPr>
-              <a:t>28.6%</a:t>
-            </a:r>
-            <a:endParaRPr b="1" lang="en-US" sz="1700" spc="-1" strike="noStrike">
-              <a:solidFill>
-                <a:srgbClr val="0e7053"/>
-              </a:solidFill>
-              <a:latin typeface="Noto Sans CJK SC"/>
-            </a:endParaRPr>
-          </a:p>
-          <a:p>
-            <a:r>
-              <a:rPr b="1" lang="zh-CN" sz="1700" spc="-1" strike="noStrike">
-                <a:solidFill>
-                  <a:srgbClr val="0e7053"/>
-                </a:solidFill>
-                <a:latin typeface="Noto Sans CJK SC"/>
-              </a:rPr>
-              <a:t>结果为团队构造仿真，不外推生产收益。</a:t>
-            </a:r>
-            <a:endParaRPr b="1" lang="en-US" sz="1700" spc="-1" strike="noStrike">
+              <a:t>官方集群未声称</a:t>
+            </a:r>
+            <a:endParaRPr b="1" lang="en-US" sz="1400" spc="-1" strike="noStrike">
               <a:solidFill>
                 <a:srgbClr val="0e7053"/>
               </a:solidFill>
@@ -4640,7 +4702,7 @@
                 </a:solidFill>
                 <a:latin typeface="Noto Sans CJK SC"/>
               </a:rPr>
-              <a:t>V0.5.1 → </a:t>
+              <a:t>V0.6.0 → </a:t>
             </a:r>
             <a:r>
               <a:rPr b="0" lang="zh-CN" sz="1800" spc="-1" strike="noStrike">
@@ -4649,25 +4711,7 @@
                 </a:solidFill>
                 <a:latin typeface="Noto Sans CJK SC"/>
               </a:rPr>
-              <a:t>复赛 </a:t>
-            </a:r>
-            <a:r>
-              <a:rPr b="0" lang="en-US" sz="1800" spc="-1" strike="noStrike">
-                <a:solidFill>
-                  <a:srgbClr val="b8c9c2"/>
-                </a:solidFill>
-                <a:latin typeface="Noto Sans CJK SC"/>
-              </a:rPr>
-              <a:t>V0.5 → </a:t>
-            </a:r>
-            <a:r>
-              <a:rPr b="0" lang="zh-CN" sz="1800" spc="-1" strike="noStrike">
-                <a:solidFill>
-                  <a:srgbClr val="b8c9c2"/>
-                </a:solidFill>
-                <a:latin typeface="Noto Sans CJK SC"/>
-              </a:rPr>
-              <a:t>决赛 </a:t>
+              <a:t>复赛公开评测 → 决赛 </a:t>
             </a:r>
             <a:r>
               <a:rPr b="0" lang="en-US" sz="1800" spc="-1" strike="noStrike">
@@ -4766,7 +4810,7 @@
                 </a:solidFill>
                 <a:latin typeface="Noto Sans CJK SC"/>
               </a:rPr>
-              <a:t>真实样例</a:t>
+              <a:t>已完成：原生连接器 </a:t>
             </a:r>
             <a:r>
               <a:rPr b="1" lang="en-US" sz="1900" spc="-1" strike="noStrike">
@@ -4775,7 +4819,7 @@
                 </a:solidFill>
                 <a:latin typeface="Noto Sans CJK SC"/>
               </a:rPr>
-              <a:t>/MCP/RAG/</a:t>
+              <a:t>+ 1 </a:t>
             </a:r>
             <a:r>
               <a:rPr b="1" lang="zh-CN" sz="1900" spc="-1" strike="noStrike">
@@ -4784,7 +4828,87 @@
                 </a:solidFill>
                 <a:latin typeface="Noto Sans CJK SC"/>
               </a:rPr>
-              <a:t>策略 → 公开缺陷集 → 真实平台现场闭环</a:t>
+              <a:t>个公开复现 </a:t>
+            </a:r>
+            <a:r>
+              <a:rPr b="1" lang="en-US" sz="1900" spc="-1" strike="noStrike">
+                <a:solidFill>
+                  <a:srgbClr val="fffdf7"/>
+                </a:solidFill>
+                <a:latin typeface="Noto Sans CJK SC"/>
+              </a:rPr>
+              <a:t>pilot</a:t>
+            </a:r>
+            <a:endParaRPr b="1" lang="en-US" sz="1900" spc="-1" strike="noStrike">
+              <a:solidFill>
+                <a:srgbClr val="fffdf7"/>
+              </a:solidFill>
+              <a:latin typeface="Noto Sans CJK SC"/>
+            </a:endParaRPr>
+          </a:p>
+          <a:p>
+            <a:r>
+              <a:rPr b="1" lang="zh-CN" sz="1900" spc="-1" strike="noStrike">
+                <a:solidFill>
+                  <a:srgbClr val="fffdf7"/>
+                </a:solidFill>
+                <a:latin typeface="Noto Sans CJK SC"/>
+              </a:rPr>
+              <a:t>下一步：</a:t>
+            </a:r>
+            <a:r>
+              <a:rPr b="1" lang="en-US" sz="1900" spc="-1" strike="noStrike">
+                <a:solidFill>
+                  <a:srgbClr val="fffdf7"/>
+                </a:solidFill>
+                <a:latin typeface="Noto Sans CJK SC"/>
+              </a:rPr>
+              <a:t>30 </a:t>
+            </a:r>
+            <a:r>
+              <a:rPr b="1" lang="zh-CN" sz="1900" spc="-1" strike="noStrike">
+                <a:solidFill>
+                  <a:srgbClr val="fffdf7"/>
+                </a:solidFill>
+                <a:latin typeface="Noto Sans CJK SC"/>
+              </a:rPr>
+              <a:t>个公开缺陷 </a:t>
+            </a:r>
+            <a:r>
+              <a:rPr b="1" lang="en-US" sz="1900" spc="-1" strike="noStrike">
+                <a:solidFill>
+                  <a:srgbClr val="fffdf7"/>
+                </a:solidFill>
+                <a:latin typeface="Noto Sans CJK SC"/>
+              </a:rPr>
+              <a:t>+ </a:t>
+            </a:r>
+            <a:r>
+              <a:rPr b="1" lang="zh-CN" sz="1900" spc="-1" strike="noStrike">
+                <a:solidFill>
+                  <a:srgbClr val="fffdf7"/>
+                </a:solidFill>
+                <a:latin typeface="Noto Sans CJK SC"/>
+              </a:rPr>
+              <a:t>三组对照 </a:t>
+            </a:r>
+            <a:r>
+              <a:rPr b="1" lang="en-US" sz="1900" spc="-1" strike="noStrike">
+                <a:solidFill>
+                  <a:srgbClr val="fffdf7"/>
+                </a:solidFill>
+                <a:latin typeface="Noto Sans CJK SC"/>
+              </a:rPr>
+              <a:t>+ </a:t>
+            </a:r>
+            <a:r>
+              <a:rPr b="1" lang="zh-CN" sz="1900" spc="-1" strike="noStrike">
+                <a:solidFill>
+                  <a:srgbClr val="fffdf7"/>
+                </a:solidFill>
+                <a:latin typeface="Noto Sans CJK SC"/>
+              </a:rPr>
+              <a:t>厂商账号闭环</a:t>
             </a:r>
             <a:endParaRPr b="1" lang="en-US" sz="1900" spc="-1" strike="noStrike">
               <a:solidFill>
@@ -4880,7 +5004,7 @@
                 </a:solidFill>
                 <a:latin typeface="Noto Sans CJK SC"/>
               </a:rPr>
-              <a:t>、策略契约、案例集和评测脚本。</a:t>
+              <a:t>、策略契约、连接器和评测脚本。</a:t>
             </a:r>
             <a:endParaRPr b="1" lang="en-US" sz="1700" spc="-1" strike="noStrike">
               <a:solidFill>

</xml_diff>